<commit_message>
feat(ILT): update silent debate generator and presentations
</commit_message>
<xml_diff>
--- a/ILT/silent-debate-ilt.pptx
+++ b/ILT/silent-debate-ilt.pptx
@@ -518,17 +518,17 @@
           <a:lstStyle/>
           <a:p>
             <a:r>
-              <a:t>60-minute run sheet — 8 min setup (slides 1-5) · 21 min rotation (7 stations x 3 min) · 20 min verdict + 60-second presentations · 10 min reflection.</a:t>
-            </a:r>
-          </a:p>
-          <a:p>
-            <a:r>
-              <a:t>MATERIALS: 7 sheets of chart paper taped around the room at eye height, one pencil colour per student, a bell/timer.</a:t>
-            </a:r>
-          </a:p>
-          <a:p>
-            <a:r>
-              <a:t>BEFORE CLASS: decide your 7 home stations and which group of 4 starts at each.</a:t>
+              <a:t>60-minute run sheet — 8 min setup (slides 1-5) · 24 min rotation (8 stations x 3 min) · 18 min verdict + 60-second presentations · 10 min reflection.</a:t>
+            </a:r>
+          </a:p>
+          <a:p>
+            <a:r>
+              <a:t>MATERIALS: 8 sheets of chart paper taped around the room at eye height, one pencil colour per student, a bell/timer.</a:t>
+            </a:r>
+          </a:p>
+          <a:p>
+            <a:r>
+              <a:t>BEFORE CLASS: decide your 8 home stations and which group of 3–4 starts at each (four groups of four, four groups of three).</a:t>
             </a:r>
           </a:p>
         </p:txBody>
@@ -808,7 +808,7 @@
           <a:lstStyle/>
           <a:p>
             <a:r>
-              <a:t>Hidden slide. Unhide and print if you want to swap out any of the 7 station statements.</a:t>
+              <a:t>PRINT PAGE 8 — tape it to chart paper at Station 8. Students open the debate here, then rebut in other colours as sheets rotate.</a:t>
             </a:r>
           </a:p>
         </p:txBody>
@@ -878,7 +878,7 @@
           <a:lstStyle/>
           <a:p>
             <a:r>
-              <a:t>Hidden slide. Unhide and print if you want to swap out any of the 7 station statements.</a:t>
+              <a:t>Hidden slide. Unhide and print if you want to swap out any of the 8 station statements.</a:t>
             </a:r>
           </a:p>
         </p:txBody>
@@ -948,7 +948,7 @@
           <a:lstStyle/>
           <a:p>
             <a:r>
-              <a:t>Hidden slide. Unhide and print if you want to swap out any of the 7 station statements.</a:t>
+              <a:t>Hidden slide. Unhide and print if you want to swap out any of the 8 station statements.</a:t>
             </a:r>
           </a:p>
         </p:txBody>
@@ -1018,7 +1018,7 @@
           <a:lstStyle/>
           <a:p>
             <a:r>
-              <a:t>3 min silent reading + 2 min picking/prepping. Then 7 speakers x 60 seconds ≈ 8 min, with quick challenges between. Keep your own tally — it feeds the exit reflection.</a:t>
+              <a:t>3 min silent reading + 2 min picking/prepping. Then 8 speakers x 60 seconds ≈ 8 min, with quick challenges between. Keep your own tally — it feeds the exit reflection.</a:t>
             </a:r>
           </a:p>
         </p:txBody>
@@ -1158,7 +1158,7 @@
           <a:lstStyle/>
           <a:p>
             <a:r>
-              <a:t>Hook — read it, pause, then move straight to the rules. Total silence starts when the first group reaches a sheet.</a:t>
+              <a:t>Hook — read it, pause, then move straight to the rules. Low-voice rule starts when the first group reaches a sheet.</a:t>
             </a:r>
           </a:p>
         </p:txBody>
@@ -1298,7 +1298,7 @@
           <a:lstStyle/>
           <a:p>
             <a:r>
-              <a:t>Assign home stations BEFORE showing this. Rotation: bell every 3 minutes, groups move clockwise (1→2→…→7→1). 7 stops x 3 min = 21 minutes. Keep the timer visible.</a:t>
+              <a:t>Assign home stations BEFORE showing this. Rotation: bell every 3 minutes, groups move clockwise (1→2→…→8→1). 8 stops x 3 min = 24 minutes. Keep the timer visible.</a:t>
             </a:r>
           </a:p>
         </p:txBody>
@@ -4806,7 +4806,7 @@
                 </a:solidFill>
                 <a:latin typeface="Arial"/>
               </a:rPr>
-              <a:t>One hour. 28 people. Zero talking.</a:t>
+              <a:t>One hour. 28 people. No shouting.</a:t>
             </a:r>
           </a:p>
         </p:txBody>
@@ -4841,7 +4841,7 @@
                 </a:solidFill>
                 <a:latin typeface="Arial"/>
               </a:rPr>
-              <a:t>Seven statements around the room. Groups of four. Your pencil is your voice.</a:t>
+              <a:t>Eight statements around the room. Groups of three or four. Your pencil is your voice.</a:t>
             </a:r>
           </a:p>
         </p:txBody>
@@ -5458,7 +5458,7 @@
 </file>
 
 <file path=ppt/slides/slide13.xml><?xml version="1.0" encoding="utf-8"?>
-<p:sld xmlns:a="http://schemas.openxmlformats.org/drawingml/2006/main" xmlns:p="http://schemas.openxmlformats.org/presentationml/2006/main" xmlns:r="http://schemas.openxmlformats.org/officeDocument/2006/relationships" show="0">
+<p:sld xmlns:a="http://schemas.openxmlformats.org/drawingml/2006/main" xmlns:p="http://schemas.openxmlformats.org/presentationml/2006/main" xmlns:r="http://schemas.openxmlformats.org/officeDocument/2006/relationships">
   <p:cSld>
     <p:bg>
       <p:bgPr>
@@ -5505,7 +5505,7 @@
                 </a:solidFill>
                 <a:latin typeface="Arial"/>
               </a:rPr>
-              <a:t>SPARE — SWAP FOR ANY STATION</a:t>
+              <a:t>STATION 8</a:t>
             </a:r>
           </a:p>
         </p:txBody>
@@ -5540,7 +5540,7 @@
                 </a:solidFill>
                 <a:latin typeface="Arial"/>
               </a:rPr>
-              <a:t>A</a:t>
+              <a:t>8</a:t>
             </a:r>
           </a:p>
         </p:txBody>
@@ -5741,7 +5741,7 @@
                 </a:solidFill>
                 <a:latin typeface="Arial"/>
               </a:rPr>
-              <a:t>B</a:t>
+              <a:t>A</a:t>
             </a:r>
           </a:p>
         </p:txBody>
@@ -5942,7 +5942,7 @@
                 </a:solidFill>
                 <a:latin typeface="Arial"/>
               </a:rPr>
-              <a:t>C</a:t>
+              <a:t>B</a:t>
             </a:r>
           </a:p>
         </p:txBody>
@@ -6143,7 +6143,7 @@
                 </a:solidFill>
                 <a:latin typeface="Arial"/>
               </a:rPr>
-              <a:t>Twenty minutes left. Back to your home sheet.</a:t>
+              <a:t>Eighteen minutes left. Back to your home sheet.</a:t>
             </a:r>
           </a:p>
         </p:txBody>
@@ -7042,7 +7042,7 @@
                 </a:solidFill>
                 <a:latin typeface="Arial"/>
               </a:rPr>
-              <a:t>without saying a word.</a:t>
+              <a:t>without raising your voice.</a:t>
             </a:r>
           </a:p>
         </p:txBody>
@@ -7077,7 +7077,7 @@
                 </a:solidFill>
                 <a:latin typeface="Arial"/>
               </a:rPr>
-              <a:t>No voices. No hands. One sheet of paper per statement — and your best reasons.</a:t>
+              <a:t>Low voices. No shouting. One sheet of paper per statement — and your best reasons.</a:t>
             </a:r>
           </a:p>
         </p:txBody>
@@ -7208,7 +7208,7 @@
                 </a:solidFill>
                 <a:latin typeface="Arial"/>
               </a:rPr>
-              <a:t>Silence is absolute.</a:t>
+              <a:t>Low voices only.</a:t>
             </a:r>
           </a:p>
           <a:p>
@@ -7224,7 +7224,7 @@
                 </a:solidFill>
                 <a:latin typeface="Arial"/>
               </a:rPr>
-              <a:t>From the first bell to the last — no whispering, no mouthing, no gestures.</a:t>
+              <a:t>Your group hears you; the next sheet doesn’t. Whisper-level, first bell to last.</a:t>
             </a:r>
           </a:p>
         </p:txBody>
@@ -7825,7 +7825,7 @@
                 </a:solidFill>
                 <a:latin typeface="Arial"/>
               </a:rPr>
-              <a:t>WHY SILENCE?</a:t>
+              <a:t>WHY QUIET?</a:t>
             </a:r>
           </a:p>
           <a:p>
@@ -7841,7 +7841,7 @@
                 </a:solidFill>
                 <a:latin typeface="Arial"/>
               </a:rPr>
-              <a:t>Silence stops the loudest voice from winning — and pushes quiet students’ ideas onto the page.</a:t>
+              <a:t>Quiet stops the loudest voice from winning — and pushes quiet students’ ideas onto the page.</a:t>
             </a:r>
           </a:p>
           <a:p>
@@ -7953,7 +7953,7 @@
                 </a:solidFill>
                 <a:latin typeface="Arial"/>
               </a:rPr>
-              <a:t>Groups of four. Each group claims one home sheet, then rotates on the bell until every sheet is visited.</a:t>
+              <a:t>Groups of three or four — eight groups. Each group claims one home sheet, then rotates on the bell until every sheet is visited.</a:t>
             </a:r>
           </a:p>
         </p:txBody>
@@ -7966,7 +7966,7 @@
         </p:nvSpPr>
         <p:spPr>
           <a:xfrm>
-            <a:off x="1372971" y="1828800"/>
+            <a:off x="673455" y="1828800"/>
             <a:ext cx="1051560" cy="1051560"/>
           </a:xfrm>
           <a:prstGeom prst="roundRect">
@@ -8021,7 +8021,7 @@
         </p:nvCxnSpPr>
         <p:spPr>
           <a:xfrm>
-            <a:off x="2470251" y="2354580"/>
+            <a:off x="1770735" y="2354580"/>
             <a:ext cx="256032" cy="0"/>
           </a:xfrm>
           <a:prstGeom prst="line">
@@ -8057,7 +8057,7 @@
         </p:nvSpPr>
         <p:spPr>
           <a:xfrm>
-            <a:off x="2772003" y="1828800"/>
+            <a:off x="2072487" y="1828800"/>
             <a:ext cx="1051560" cy="1051560"/>
           </a:xfrm>
           <a:prstGeom prst="roundRect">
@@ -8112,7 +8112,7 @@
         </p:nvCxnSpPr>
         <p:spPr>
           <a:xfrm>
-            <a:off x="3869283" y="2354580"/>
+            <a:off x="3169767" y="2354580"/>
             <a:ext cx="256032" cy="0"/>
           </a:xfrm>
           <a:prstGeom prst="line">
@@ -8148,7 +8148,7 @@
         </p:nvSpPr>
         <p:spPr>
           <a:xfrm>
-            <a:off x="4171035" y="1828800"/>
+            <a:off x="3471519" y="1828800"/>
             <a:ext cx="1051560" cy="1051560"/>
           </a:xfrm>
           <a:prstGeom prst="roundRect">
@@ -8203,7 +8203,7 @@
         </p:nvCxnSpPr>
         <p:spPr>
           <a:xfrm>
-            <a:off x="5268315" y="2354580"/>
+            <a:off x="4568799" y="2354580"/>
             <a:ext cx="256032" cy="0"/>
           </a:xfrm>
           <a:prstGeom prst="line">
@@ -8239,7 +8239,7 @@
         </p:nvSpPr>
         <p:spPr>
           <a:xfrm>
-            <a:off x="5570067" y="1828800"/>
+            <a:off x="4870551" y="1828800"/>
             <a:ext cx="1051560" cy="1051560"/>
           </a:xfrm>
           <a:prstGeom prst="roundRect">
@@ -8294,7 +8294,7 @@
         </p:nvCxnSpPr>
         <p:spPr>
           <a:xfrm>
-            <a:off x="6667347" y="2354580"/>
+            <a:off x="5967831" y="2354580"/>
             <a:ext cx="256032" cy="0"/>
           </a:xfrm>
           <a:prstGeom prst="line">
@@ -8330,7 +8330,7 @@
         </p:nvSpPr>
         <p:spPr>
           <a:xfrm>
-            <a:off x="6969099" y="1828800"/>
+            <a:off x="6269583" y="1828800"/>
             <a:ext cx="1051560" cy="1051560"/>
           </a:xfrm>
           <a:prstGeom prst="roundRect">
@@ -8385,7 +8385,7 @@
         </p:nvCxnSpPr>
         <p:spPr>
           <a:xfrm>
-            <a:off x="8066379" y="2354580"/>
+            <a:off x="7366863" y="2354580"/>
             <a:ext cx="256032" cy="0"/>
           </a:xfrm>
           <a:prstGeom prst="line">
@@ -8421,7 +8421,7 @@
         </p:nvSpPr>
         <p:spPr>
           <a:xfrm>
-            <a:off x="8368131" y="1828800"/>
+            <a:off x="7668615" y="1828800"/>
             <a:ext cx="1051560" cy="1051560"/>
           </a:xfrm>
           <a:prstGeom prst="roundRect">
@@ -8476,7 +8476,7 @@
         </p:nvCxnSpPr>
         <p:spPr>
           <a:xfrm>
-            <a:off x="9465411" y="2354580"/>
+            <a:off x="8765895" y="2354580"/>
             <a:ext cx="256032" cy="0"/>
           </a:xfrm>
           <a:prstGeom prst="line">
@@ -8512,7 +8512,7 @@
         </p:nvSpPr>
         <p:spPr>
           <a:xfrm>
-            <a:off x="9767163" y="1828800"/>
+            <a:off x="9067647" y="1828800"/>
             <a:ext cx="1051560" cy="1051560"/>
           </a:xfrm>
           <a:prstGeom prst="roundRect">
@@ -8567,7 +8567,98 @@
         </p:nvCxnSpPr>
         <p:spPr>
           <a:xfrm>
-            <a:off x="10292943" y="3451859"/>
+            <a:off x="10164927" y="2354580"/>
+            <a:ext cx="256032" cy="0"/>
+          </a:xfrm>
+          <a:prstGeom prst="line">
+            <a:avLst/>
+          </a:prstGeom>
+          <a:ln w="25400">
+            <a:solidFill>
+              <a:srgbClr val="F56A6A"/>
+            </a:solidFill>
+          </a:ln>
+          <a:effectLst/>
+        </p:spPr>
+        <p:style>
+          <a:lnRef idx="2">
+            <a:schemeClr val="accent1"/>
+          </a:lnRef>
+          <a:fillRef idx="0">
+            <a:schemeClr val="accent1"/>
+          </a:fillRef>
+          <a:effectRef idx="1">
+            <a:schemeClr val="accent1"/>
+          </a:effectRef>
+          <a:fontRef idx="minor">
+            <a:schemeClr val="tx1"/>
+          </a:fontRef>
+        </p:style>
+      </p:cxnSp>
+      <p:sp>
+        <p:nvSpPr>
+          <p:cNvPr id="18" name="Rounded Rectangle 17"/>
+          <p:cNvSpPr/>
+          <p:nvPr/>
+        </p:nvSpPr>
+        <p:spPr>
+          <a:xfrm>
+            <a:off x="10466679" y="1828800"/>
+            <a:ext cx="1051560" cy="1051560"/>
+          </a:xfrm>
+          <a:prstGeom prst="roundRect">
+            <a:avLst>
+              <a:gd name="adj" fmla="val 18000"/>
+            </a:avLst>
+          </a:prstGeom>
+          <a:solidFill>
+            <a:srgbClr val="F56A6A"/>
+          </a:solidFill>
+          <a:ln>
+            <a:noFill/>
+          </a:ln>
+          <a:effectLst/>
+        </p:spPr>
+        <p:style>
+          <a:lnRef idx="1">
+            <a:schemeClr val="accent1"/>
+          </a:lnRef>
+          <a:fillRef idx="3">
+            <a:schemeClr val="accent1"/>
+          </a:fillRef>
+          <a:effectRef idx="2">
+            <a:schemeClr val="accent1"/>
+          </a:effectRef>
+          <a:fontRef idx="minor">
+            <a:schemeClr val="lt1"/>
+          </a:fontRef>
+        </p:style>
+        <p:txBody>
+          <a:bodyPr rtlCol="0" anchor="ctr" lIns="0" rIns="0" tIns="0" bIns="0"/>
+          <a:lstStyle/>
+          <a:p>
+            <a:pPr algn="ctr"/>
+            <a:r>
+              <a:rPr sz="3000" b="1">
+                <a:solidFill>
+                  <a:srgbClr val="FFFFFF"/>
+                </a:solidFill>
+                <a:latin typeface="Arial"/>
+              </a:rPr>
+              <a:t>8</a:t>
+            </a:r>
+          </a:p>
+        </p:txBody>
+      </p:sp>
+      <p:cxnSp>
+        <p:nvCxnSpPr>
+          <p:cNvPr id="19" name="Connector 18"/>
+          <p:cNvCxnSpPr/>
+          <p:nvPr/>
+        </p:nvCxnSpPr>
+        <p:spPr>
+          <a:xfrm>
+            <a:off x="10992459" y="3451859"/>
             <a:ext cx="0" cy="68581"/>
           </a:xfrm>
           <a:prstGeom prst="line">
@@ -8598,14 +8689,14 @@
       </p:cxnSp>
       <p:cxnSp>
         <p:nvCxnSpPr>
-          <p:cNvPr id="18" name="Connector 17"/>
+          <p:cNvPr id="20" name="Connector 19"/>
           <p:cNvCxnSpPr/>
           <p:nvPr/>
         </p:nvCxnSpPr>
         <p:spPr>
           <a:xfrm flipH="1">
-            <a:off x="1898751" y="3520440"/>
-            <a:ext cx="8394192" cy="0"/>
+            <a:off x="1199235" y="3520440"/>
+            <a:ext cx="9793224" cy="0"/>
           </a:xfrm>
           <a:prstGeom prst="line">
             <a:avLst/>
@@ -8635,13 +8726,13 @@
       </p:cxnSp>
       <p:cxnSp>
         <p:nvCxnSpPr>
-          <p:cNvPr id="19" name="Connector 18"/>
+          <p:cNvPr id="21" name="Connector 20"/>
           <p:cNvCxnSpPr/>
           <p:nvPr/>
         </p:nvCxnSpPr>
         <p:spPr>
           <a:xfrm flipV="1">
-            <a:off x="1898751" y="3479291"/>
+            <a:off x="1199235" y="3479291"/>
             <a:ext cx="0" cy="41149"/>
           </a:xfrm>
           <a:prstGeom prst="line">
@@ -8673,7 +8764,7 @@
       </p:cxnSp>
       <p:sp>
         <p:nvSpPr>
-          <p:cNvPr id="20" name="TextBox 19"/>
+          <p:cNvPr id="22" name="TextBox 21"/>
           <p:cNvSpPr txBox="1"/>
           <p:nvPr/>
         </p:nvSpPr>
@@ -8701,14 +8792,14 @@
                 </a:solidFill>
                 <a:latin typeface="Arial"/>
               </a:rPr>
-              <a:t>after station 7 → station 1</a:t>
-            </a:r>
-          </a:p>
-        </p:txBody>
-      </p:sp>
-      <p:sp>
-        <p:nvSpPr>
-          <p:cNvPr id="21" name="TextBox 20"/>
+              <a:t>after station 8 → station 1</a:t>
+            </a:r>
+          </a:p>
+        </p:txBody>
+      </p:sp>
+      <p:sp>
+        <p:nvSpPr>
+          <p:cNvPr id="23" name="TextBox 22"/>
           <p:cNvSpPr txBox="1"/>
           <p:nvPr/>
         </p:nvSpPr>
@@ -8736,7 +8827,7 @@
                 </a:solidFill>
                 <a:latin typeface="Arial"/>
               </a:rPr>
-              <a:t>7</a:t>
+              <a:t>8</a:t>
             </a:r>
           </a:p>
           <a:p>
@@ -8759,7 +8850,7 @@
       </p:sp>
       <p:sp>
         <p:nvSpPr>
-          <p:cNvPr id="22" name="TextBox 21"/>
+          <p:cNvPr id="24" name="TextBox 23"/>
           <p:cNvSpPr txBox="1"/>
           <p:nvPr/>
         </p:nvSpPr>
@@ -8810,7 +8901,7 @@
       </p:sp>
       <p:sp>
         <p:nvSpPr>
-          <p:cNvPr id="23" name="TextBox 22"/>
+          <p:cNvPr id="25" name="TextBox 24"/>
           <p:cNvSpPr txBox="1"/>
           <p:nvPr/>
         </p:nvSpPr>
@@ -8838,7 +8929,7 @@
                 </a:solidFill>
                 <a:latin typeface="Arial"/>
               </a:rPr>
-              <a:t>21 min</a:t>
+              <a:t>24 min</a:t>
             </a:r>
           </a:p>
           <a:p>
@@ -8861,7 +8952,7 @@
       </p:sp>
       <p:sp>
         <p:nvSpPr>
-          <p:cNvPr id="24" name="TextBox 23"/>
+          <p:cNvPr id="26" name="TextBox 25"/>
           <p:cNvSpPr txBox="1"/>
           <p:nvPr/>
         </p:nvSpPr>

</xml_diff>